<commit_message>
Add Chapter 9.5: Open-Source vs. Managed/Proprietary Trade-offs
Names the two independent axes (open source vs. proprietary code,
self-hosted vs. managed operation) behind every product in 9.2 and 9.3,
and the cost, control, and lock-in trade-offs that follow, without
declaring a universal winner. Includes a matching slide deck and a new
glossary entry.

Also retroactively corrects Chapter 9.2's two now-outdated product
names (LangGraph Platform -> LangSmith Deployment, renamed October
2025; CrewAI's AMP Suite -> CrewAI AMP) in its prose, comparison table,
glossary entries, and deck.
</commit_message>
<xml_diff>
--- a/decks/9.2-Orchestration-Frameworks-at-a-Glance-Slides.pptx
+++ b/decks/9.2-Orchestration-Frameworks-at-a-Glance-Slides.pptx
@@ -3653,7 +3653,7 @@
                   <a:srgbClr val="6B7280"/>
                 </a:solidFill>
               </a:rPr>
-              <a:t>  MIT-licensed core, plus LangChain's own paid LangSmith (observability/eval) and LangGraph Platform (managed deployment).</a:t>
+              <a:t>  MIT-licensed core, plus LangChain's own paid LangSmith (observability/eval) and LangSmith Deployment, renamed from LangGraph Platform in Oct 2025 (managed deployment).</a:t>
             </a:r>
           </a:p>
           <a:p>
@@ -3699,7 +3699,7 @@
                   <a:srgbClr val="6B7280"/>
                 </a:solidFill>
               </a:rPr>
-              <a:t>  MIT-licensed core, plus a paid "AMP Suite" control plane adding managed deployment, observability, governance, and enterprise support.</a:t>
+              <a:t>  MIT-licensed core, plus a paid "CrewAI AMP" control plane adding managed deployment, observability, governance, and enterprise support.</a:t>
             </a:r>
           </a:p>
         </p:txBody>
@@ -4454,7 +4454,7 @@
                             <a:srgbClr val="1F2D3D"/>
                           </a:solidFill>
                         </a:rPr>
-                        <a:t>MIT + paid LangSmith / Platform</a:t>
+                        <a:t>MIT + paid LangSmith / Deployment</a:t>
                       </a:r>
                     </a:p>
                   </a:txBody>
@@ -4475,7 +4475,7 @@
                             <a:srgbClr val="1F2D3D"/>
                           </a:solidFill>
                         </a:rPr>
-                        <a:t>MIT + paid AMP Suite</a:t>
+                        <a:t>MIT + paid CrewAI AMP</a:t>
                       </a:r>
                     </a:p>
                   </a:txBody>

</xml_diff>